<commit_message>
Slides: sessions 25 and 29; others in progress
Co-Authored-By: Claude Opus 5.5 <noreply@anthropic.com>
Claude-Session: https://claude.ai/code/session_01XkzKv8pUGMF9AsqSCMpnBq
</commit_message>
<xml_diff>
--- a/slides/decks/s26-hemoglobinopathies.pptx
+++ b/slides/decks/s26-hemoglobinopathies.pptx
@@ -135,13 +135,13 @@
   <p:extLst>
     <p:ext uri="{521415D9-36F7-43E2-AB2F-B90AF26B5E84}">
       <p14:sectionLst xmlns:p14="http://schemas.microsoft.com/office/powerpoint/2010/main">
-        <p14:section name="Opening" id="{9af01977-e75c-f984-409a-f2831db1404f}">
+        <p14:section name="Opening" id="{dc7065c2-3f38-6ab0-18fc-84b35cf3d35e}">
           <p14:sldIdLst>
             <p14:sldId id="256"/>
             <p14:sldId id="257"/>
           </p14:sldIdLst>
         </p14:section>
-        <p14:section name="Sickle cell disease" id="{1a1893cb-1936-f714-098c-d83c4131178b}">
+        <p14:section name="Sickle cell disease" id="{126230ba-8258-7128-c097-cebddefe9bbb}">
           <p14:sldIdLst>
             <p14:sldId id="258"/>
             <p14:sldId id="259"/>
@@ -149,13 +149,13 @@
             <p14:sldId id="261"/>
           </p14:sldIdLst>
         </p14:section>
-        <p14:section name="SCD conditioning and donors" id="{51c4346d-529e-1419-4e39-fa2c44188221}">
+        <p14:section name="SCD conditioning and donors" id="{1a33fb33-6e79-fe75-865c-8c45db575cfb}">
           <p14:sldIdLst>
             <p14:sldId id="262"/>
             <p14:sldId id="263"/>
           </p14:sldIdLst>
         </p14:section>
-        <p14:section name="Thalassaemia" id="{cb096a7e-657d-67cd-ed65-a686de1d7686}">
+        <p14:section name="Thalassaemia" id="{15480bf3-0860-851e-85ea-d99d8344f453}">
           <p14:sldIdLst>
             <p14:sldId id="264"/>
             <p14:sldId id="265"/>
@@ -164,14 +164,14 @@
             <p14:sldId id="268"/>
           </p14:sldIdLst>
         </p14:section>
-        <p14:section name="Chimerism, gene therapy and follow-up" id="{019d7f62-57ef-92bd-f31c-d640f49698a5}">
+        <p14:section name="Chimerism, gene therapy and follow-up" id="{8ad3ab91-313e-7bfd-db13-3d27daed0019}">
           <p14:sldIdLst>
             <p14:sldId id="269"/>
             <p14:sldId id="270"/>
             <p14:sldId id="271"/>
           </p14:sldIdLst>
         </p14:section>
-        <p14:section name="Board questions" id="{d8fdcd00-d79f-e0ff-c63f-ce25cbff48e6}">
+        <p14:section name="Board questions" id="{9c4f5eb9-e9c1-3047-f36d-1d012b270f2b}">
           <p14:sldIdLst>
             <p14:sldId id="272"/>
             <p14:sldId id="273"/>
@@ -181,7 +181,7 @@
             <p14:sldId id="277"/>
           </p14:sldIdLst>
         </p14:section>
-        <p14:section name="References" id="{3a85230e-c80f-9cdc-42cf-ba15c5458fe3}">
+        <p14:section name="References" id="{ada862bf-42a5-d49c-50b8-21849f57100d}">
           <p14:sldIdLst>
             <p14:sldId id="278"/>
             <p14:sldId id="279"/>
@@ -189,7 +189,7 @@
             <p14:sldId id="281"/>
           </p14:sldIdLst>
         </p14:section>
-        <p14:section name="Backup" id="{93576aa3-b8c3-42c4-751b-88dcc42f4793}">
+        <p14:section name="Backup" id="{96bddbe6-56ef-aad3-34d0-6cdd66f8aad9}">
           <p14:sldIdLst>
             <p14:sldId id="282"/>
             <p14:sldId id="283"/>
@@ -616,7 +616,7 @@
             </a:pPr>
             <a:r>
               <a:rPr lang="en-US" dirty="0"/>
-              <a:t>各位好，第 26 堂談 hemoglobinopathy 的移植，也就是 sickle cell disease 和 thalassemia，對應 EBMT Handbook 第 80 章。兩個病都是非惡性疾病，移植的目標是治癒，同時不留下 GVHD 和長期毒性。接下來會講年齡切點、Pesaro 分級、conditioning 和 donor 選擇，最後用三題 board-style 題目收尾。</a:t>
+              <a:t>各位好，第 26 堂談 hemoglobinopathy 的移植，也就是 sickle cell disease 和 thalassemia，對應 EBMT Handbook 第 80 章。兩個病都是非惡性疾病，移植的目標是治癒，同時不留下 GVHD 和長期毒性。接下來會講年齡切點、Pesaro 分級、conditioning 和 donor 選擇，最後用三題 board-style 題目收尾。地中海型貧血和鐮刀型貧血的移植邏輯很像，但有幾個關鍵地方剛好相反。</a:t>
             </a:r>
           </a:p>
         </p:txBody>
@@ -744,6 +744,17 @@
               <a:t>考題最常混淆的就是 2 cm 和 5 cm。2 cm 是 Pesaro 本身的肝腫大切點，5 cm 加 7 歲是 class 3 裡的 very-high-risk 子分組。另外，Pesaro 在成人沒有預測力，題目如果是 25 歲的病人，就不能直接套用。</a:t>
             </a:r>
           </a:p>
+          <a:p>
+            <a:pPr>
+              <a:spcAft>
+                <a:spcPts val="600"/>
+              </a:spcAft>
+            </a:pPr>
+            <a:r>
+              <a:rPr lang="en-US" dirty="0"/>
+              <a:t>臨床上 Pesaro 提醒我們，鐵螯合的品質和肝臟狀態會直接影響移植風險。螯合做得好、肝臟沒有腫大和纖維化，病人就留在低風險組，所以移植的討論不要等到肝臟出問題才開始。</a:t>
+            </a:r>
+          </a:p>
         </p:txBody>
       </p:sp>
       <p:sp>
@@ -887,6 +898,17 @@
               </a:spcAft>
             </a:pPr>
             <a:r>
+              <a:rPr lang="en-US" dirty="0"/>
+              <a:t>這張表要和前一張一起看。Pesaro 建立在 busulfan 加 cyclophosphamide 的年代，conditioning 改變以後，它的預測力有一大部分被年齡取代。考題如果給一個 16 歲以上的 thalassemia 病人，要想到 EFS 明顯下降、graft failure 增加。Fig. 80.4 的分組是六歲以下，書上文字寫的是 7 歲以前，兩者差一歲，背的時候以文字的 7 歲為準。</a:t>
+            </a:r>
+          </a:p>
+          <a:p>
+            <a:pPr>
+              <a:spcAft>
+                <a:spcPts val="600"/>
+              </a:spcAft>
+            </a:pPr>
+            <a:r>
               <a:rPr lang="en-US" b="1" dirty="0"/>
               <a:t>講者提醒（不念出來）：</a:t>
             </a:r>
@@ -1038,6 +1060,17 @@
               <a:t>GVHD 預防加上 abatacept，可以降低 day 100 的嚴重 acute GVHD，又不影響 engraftment 和存活。含靜脈 busulfan 的 conditioning 有用 defibrotide 預防 SOS/VOD 的經驗，不過很多國家只核准它用於治療；依 busulfan 藥物動力學調整劑量，也能改善 engraftment、減少毒性。</a:t>
             </a:r>
           </a:p>
+          <a:p>
+            <a:pPr>
+              <a:spcAft>
+                <a:spcPts val="600"/>
+              </a:spcAft>
+            </a:pPr>
+            <a:r>
+              <a:rPr lang="en-US" dirty="0"/>
+              <a:t>這張表的劑量都可能變成考題。Thiotepa 10 mg/kg、hydroxyurea 30 mg/kg、azathioprine 3 mg/kg，三個數字要分清楚。Thalassemia 的 rejection 風險特別高，因為骨髓過度活躍、又被大量輸血致敏，所以表上一半的措施是為了防止 rejection，包括 thiotepa、移植前壓抑造血和 ATG；另一半是為了降低毒性，例如 treosulfan、abatacept 和 busulfan 濃度監測。不過 busulfan 藥物動力學監測，目前只有少數機構做得到。</a:t>
+            </a:r>
+          </a:p>
         </p:txBody>
       </p:sp>
       <p:sp>
@@ -1163,6 +1196,17 @@
               <a:t>Haplo 早期用 CD34 selection，感染和 graft failure 都多。現在改用 TCRαβ/CD19 depletion 或 PTCy，結果已接近 related 和 unrelated 移植。幹細胞來源以骨髓為佳，GVHD 較少；體重大的病人，在 GVHD 預防足夠下也可以用周邊血。</a:t>
             </a:r>
           </a:p>
+          <a:p>
+            <a:pPr>
+              <a:spcAft>
+                <a:spcPts val="600"/>
+              </a:spcAft>
+            </a:pPr>
+            <a:r>
+              <a:rPr lang="en-US" dirty="0"/>
+              <a:t>這張是今天最重要的對比之一。SCD 的 MUD 比 sibling 差，thalassemia 的 MUD 和 related donor 相當，考試只要把兩個結論分開記。依書上的結論推論，沒有 sibling 的 thalassemia 病人，MUD 是首先要找的標準選項，haplo 是正在追上的替代方案。Cord blood 因為 graft failure 高，要看細胞數再決定；也可以合併第三方 mesenchymal stromal cell 或 T-cell depleted haplo 細胞，來彌補細胞數不足。</a:t>
+            </a:r>
+          </a:p>
         </p:txBody>
       </p:sp>
       <p:sp>
@@ -1288,6 +1332,17 @@
               <a:t>Thalassemia 的 mixed chimerism 通常由 T 細胞驅動，可能走向 poor graft function 或 clonal evolution，所以要讓它穩定下來。第一步是加強免疫抑制，持續或加上 MMF 來提高 donor 比例。DLI 是替代方案，但有 GVHD 風險，效果也可能有限。Haplo 和 RIC 這類高風險移植，可以在移植前先做 pretransplantation immunosuppression，降低 mixed chimerism 和 graft failure。</a:t>
             </a:r>
           </a:p>
+          <a:p>
+            <a:pPr>
+              <a:spcAft>
+                <a:spcPts val="600"/>
+              </a:spcAft>
+            </a:pPr>
+            <a:r>
+              <a:rPr lang="en-US" dirty="0"/>
+              <a:t>追蹤時要定期做 split chimerism，不要只看 whole blood。Whole blood 的 donor 比例下降，可能是 T 細胞在變，也可能是 myeloid 在流失，兩者的處理不同。等一下第二題就是這個情境。</a:t>
+            </a:r>
+          </a:p>
         </p:txBody>
       </p:sp>
       <p:sp>
@@ -1420,6 +1475,17 @@
               </a:spcAft>
             </a:pPr>
             <a:r>
+              <a:rPr lang="en-US" dirty="0"/>
+              <a:t>兩個病在 gene therapy 的安全性訊號不一樣。SCD 有白血病的報告，所以書上提出一個假說，SCD 病人可能本來就帶有 CHIP 這類前白血病變化，未來在移植或基因治療前也許需要篩檢。Thalassemia 目前則沒有惡性腫瘤報告。這些療法普及以後，移植的適應症也會改變，誰該優先接受，Baronciani 2021 提出了決策流程。</a:t>
+            </a:r>
+          </a:p>
+          <a:p>
+            <a:pPr>
+              <a:spcAft>
+                <a:spcPts val="600"/>
+              </a:spcAft>
+            </a:pPr>
+            <a:r>
               <a:rPr lang="en-US" b="1" dirty="0"/>
               <a:t>講者提醒（不念出來）：</a:t>
             </a:r>
@@ -1571,6 +1637,17 @@
               <a:t>治癒的病人生活品質明顯改善，但仍需要終身追蹤，處理移植前就存在的器官損傷，以及移植本身的晚期併發症。</a:t>
             </a:r>
           </a:p>
+          <a:p>
+            <a:pPr>
+              <a:spcAft>
+                <a:spcPts val="600"/>
+              </a:spcAft>
+            </a:pPr>
+            <a:r>
+              <a:rPr lang="en-US" dirty="0"/>
+              <a:t>這張和前面 Pesaro 的鐵負荷其實是同一條線。移植前的鐵負荷影響移植風險，移植後殘留的鐵仍要主動移除，治癒並不等於追蹤結束。題目若寫移植後一個月就開始 deferasirox，就不符合這個試驗的設計。</a:t>
+            </a:r>
+          </a:p>
         </p:txBody>
       </p:sp>
       <p:sp>
@@ -1692,6 +1769,17 @@
               </a:spcAft>
             </a:pPr>
             <a:r>
+              <a:rPr lang="en-US" dirty="0"/>
+              <a:t>先想清楚兩件事，這個年齡落在 13 歲切點的哪一邊，以及 SCD 採集幹細胞有什麼禁忌。選項 C 到 E 分別考的是幹細胞採集、haplo 的演進和 chimerism。</a:t>
+            </a:r>
+          </a:p>
+          <a:p>
+            <a:pPr>
+              <a:spcAft>
+                <a:spcPts val="600"/>
+              </a:spcAft>
+            </a:pPr>
+            <a:r>
               <a:rPr lang="en-US" b="1" dirty="0"/>
               <a:t>[Pause for answers.]</a:t>
             </a:r>
@@ -1810,6 +1898,17 @@
               <a:t>最容易選的陷阱是 A。MUD 和 related donor 結果相當，是 thalassemia 的結論，搬到 SCD 就錯了。C 錯，SCD 病人禁用 G-CSF。D 錯，43% 是早期 haplo 的數字，PTCy 或 TCRαβ/CD19 depletion 之後已接近 sibling。E 錯，myeloid 是 donor 的 mixed chimerism 就足以治療。</a:t>
             </a:r>
           </a:p>
+          <a:p>
+            <a:pPr>
+              <a:spcAft>
+                <a:spcPts val="600"/>
+              </a:spcAft>
+            </a:pPr>
+            <a:r>
+              <a:rPr lang="en-US" dirty="0"/>
+              <a:t>這題的核心是把兩個病的 donor 結論分開背。Thalassemia 的 MUD 是標準選項，SCD 的 MUD 則要考慮較差的結果；這個 14 歲病人沒有 sibling，haplo 也是書上支持的根治選項。</a:t>
+            </a:r>
+          </a:p>
         </p:txBody>
       </p:sp>
       <p:sp>
@@ -1931,6 +2030,17 @@
               </a:spcAft>
             </a:pPr>
             <a:r>
+              <a:rPr lang="en-US" dirty="0"/>
+              <a:t>題目刻意給了幾個線索。病人目前不需輸血，表示 graft 仍在運作；donor 比例在下降，而且下降的是 T 細胞這一側。選項包括加強免疫抑制、DLI、觀察、再移植和鐵螯合，請找出書上建議的第一步。</a:t>
+            </a:r>
+          </a:p>
+          <a:p>
+            <a:pPr>
+              <a:spcAft>
+                <a:spcPts val="600"/>
+              </a:spcAft>
+            </a:pPr>
+            <a:r>
               <a:rPr lang="en-US" b="1" dirty="0"/>
               <a:t>[Pause for answers.]</a:t>
             </a:r>
@@ -2060,6 +2170,17 @@
               <a:t>最後一段放兩個病共通的議題，包括 mixed chimerism、gene therapy 和移植後的鐵負荷，再用三題練習收尾。兩個病在 unrelated donor 上的結論剛好相反，這是今天最值得帶走的對比，後面會反覆回到這一點。</a:t>
             </a:r>
           </a:p>
+          <a:p>
+            <a:pPr>
+              <a:spcAft>
+                <a:spcPts val="600"/>
+              </a:spcAft>
+            </a:pPr>
+            <a:r>
+              <a:rPr lang="en-US" dirty="0"/>
+              <a:t>每一段的時間標在右邊。前兩段合計大約九分鐘，thalassemia 八分半，最後一段含題目九分多鐘。三題分別對應 donor 選擇、mixed chimerism 和 Pesaro 分級。</a:t>
+            </a:r>
+          </a:p>
         </p:txBody>
       </p:sp>
       <p:sp>
@@ -2174,6 +2295,17 @@
               <a:t>常見的錯誤是 B。DLI 是替代方案，但有 GVHD 風險，效果也有限，不是第一步。C 錯，donor 比例持續下滑可能走向 poor graft function 或 clonal evolution，要處理。D 太激進。E 的 deferasirox 是在移植六個月後用來移除鐵，和 chimerism 無關。</a:t>
             </a:r>
           </a:p>
+          <a:p>
+            <a:pPr>
+              <a:spcAft>
+                <a:spcPts val="600"/>
+              </a:spcAft>
+            </a:pPr>
+            <a:r>
+              <a:rPr lang="en-US" dirty="0"/>
+              <a:t>臨床上，加 MMF 的同時要密集追蹤 split chimerism，確認 donor 比例回升。加強免疫抑制後仍持續下降，才考慮 DLI，而且要準備處理 GVHD。</a:t>
+            </a:r>
+          </a:p>
         </p:txBody>
       </p:sp>
       <p:sp>
@@ -2295,6 +2427,17 @@
               </a:spcAft>
             </a:pPr>
             <a:r>
+              <a:rPr lang="en-US" dirty="0"/>
+              <a:t>也留意這是兒童，而 Pesaro 的驗證族群正好是兒童。選項裡有 2 cm 和 5 cm 兩個數字，還有 ferritin 和成人的敘述，每一個都對應前面一張投影片。</a:t>
+            </a:r>
+          </a:p>
+          <a:p>
+            <a:pPr>
+              <a:spcAft>
+                <a:spcPts val="600"/>
+              </a:spcAft>
+            </a:pPr>
+            <a:r>
               <a:rPr lang="en-US" b="1" dirty="0"/>
               <a:t>[Pause for answers.]</a:t>
             </a:r>
@@ -2413,6 +2556,17 @@
               <a:t>最常見的錯誤是 A，把 5 cm 搞混了。5 cm 加上年齡大於 7 歲，是 Mathews 在 class 3 裡再分出的 very-high-risk 組。C 錯，Pesaro 在成人預測力不好。D 錯，ferritin 看不出纖維化。E 錯，移植仍是唯一的標準根治方法。</a:t>
             </a:r>
           </a:p>
+          <a:p>
+            <a:pPr>
+              <a:spcAft>
+                <a:spcPts val="600"/>
+              </a:spcAft>
+            </a:pPr>
+            <a:r>
+              <a:rPr lang="en-US" dirty="0"/>
+              <a:t>這個病人的肝纖維化是靠切片確認的，ferritin 只能當參考。中心經驗本身也是預後因子。</a:t>
+            </a:r>
+          </a:p>
         </p:txBody>
       </p:sp>
       <p:sp>
@@ -3161,6 +3315,17 @@
               </a:spcAft>
             </a:pPr>
             <a:r>
+              <a:rPr lang="en-US" dirty="0"/>
+              <a:t>在門診跟家屬談移植時，常被問到為什麼不繼續用藥就好。書上的立場是，藥物控制的是急性事件和溶血，卻沒辦法保證阻止慢性血管病變，所以移植要在器官損傷出現以前就開始討論。</a:t>
+            </a:r>
+          </a:p>
+          <a:p>
+            <a:pPr>
+              <a:spcAft>
+                <a:spcPts val="600"/>
+              </a:spcAft>
+            </a:pPr>
+            <a:r>
               <a:rPr lang="en-US" b="1" dirty="0"/>
               <a:t>講者提醒（不念出來）：</a:t>
             </a:r>
@@ -3301,6 +3466,17 @@
               <a:t>Thalassemia 成人只有 84.4%，這個落差呼應等一下要講的年齡效應，thalassemia 移植越早做越好。</a:t>
             </a:r>
           </a:p>
+          <a:p>
+            <a:pPr>
+              <a:spcAft>
+                <a:spcPts val="600"/>
+              </a:spcAft>
+            </a:pPr>
+            <a:r>
+              <a:rPr lang="en-US" dirty="0"/>
+              <a:t>這四個數字也提醒我們，移植在 hemoglobinopathy 已經不是實驗性治療。但書上也列出限制移植使用的障礙，包括找不到 donor、資訊不足、對移植的理解有限，還有非惡性疾病的病人和家屬，對 rejection、GVHD 和移植相關死亡的顧慮。</a:t>
+            </a:r>
+          </a:p>
         </p:txBody>
       </p:sp>
       <p:sp>
@@ -3437,6 +3613,17 @@
               <a:t>移植前要完整評估器官損傷，腦灌流、骨壞死都有逆轉的報告，但要先和病人談清楚期待。</a:t>
             </a:r>
           </a:p>
+          <a:p>
+            <a:pPr>
+              <a:spcAft>
+                <a:spcPts val="600"/>
+              </a:spcAft>
+            </a:pPr>
+            <a:r>
+              <a:rPr lang="en-US" dirty="0"/>
+              <a:t>另外兩個資源也值得一提。Family-directed cord blood banking，在已有 SCD 孩子的家庭保存手足的臍帶血；Dovern 2023 的調查則顯示，成人 SCD 移植後身體、心理和社會健康都有改善。</a:t>
+            </a:r>
+          </a:p>
         </p:txBody>
       </p:sp>
       <p:sp>
@@ -3591,6 +3778,17 @@
               </a:spcAft>
             </a:pPr>
             <a:r>
+              <a:rPr lang="en-US" dirty="0"/>
+              <a:t>考試比較可能考的是這張圖的方向，年紀越大，越往 haplo 和基因治療走。</a:t>
+            </a:r>
+          </a:p>
+          <a:p>
+            <a:pPr>
+              <a:spcAft>
+                <a:spcPts val="600"/>
+              </a:spcAft>
+            </a:pPr>
+            <a:r>
               <a:rPr lang="en-US" b="1" dirty="0"/>
               <a:t>講者提醒（不念出來）：</a:t>
             </a:r>
@@ -3742,6 +3940,17 @@
               <a:t>考試常把 SCD 跟 thalassemia 的 conditioning 放在一起比。SCD 這邊的關鍵字是 MAC 加 ATG、FTT，以及在特定族群使用的 RIC。</a:t>
             </a:r>
           </a:p>
+          <a:p>
+            <a:pPr>
+              <a:spcAft>
+                <a:spcPts val="600"/>
+              </a:spcAft>
+            </a:pPr>
+            <a:r>
+              <a:rPr lang="en-US" dirty="0"/>
+              <a:t>選 conditioning 時，年齡和器官狀態要一起考慮。小孩的器官多半還好，重點放在生育力；成人常已有 SCD 造成的器官損傷，重點放在降低毒性。FTT 的優勢，書上引用的是 EBMT registry 資料，以及 Foell 2020 和 Faraci 2019 的研究。RIC 後 mixed chimerism 更常見，但在 hemoglobinopathy 這不一定是壞事，第四段會專門講。</a:t>
+            </a:r>
+          </a:p>
         </p:txBody>
       </p:sp>
       <p:sp>
@@ -3878,6 +4087,17 @@
               <a:t>Unrelated donor 在 SCD 的 GVHD 風險仍高，haplo 的結果則越來越接近 sibling。對沒有 matched donor 的多數 SCD 病人，haplo 已經是可行的根治選項。</a:t>
             </a:r>
           </a:p>
+          <a:p>
+            <a:pPr>
+              <a:spcAft>
+                <a:spcPts val="600"/>
+              </a:spcAft>
+            </a:pPr>
+            <a:r>
+              <a:rPr lang="en-US" dirty="0"/>
+              <a:t>這條演進線有兩個訊息。Haplo 在 SCD 的主要障礙是 graft failure，所以改良方向都在加強 conditioning，例如加入 thiotepa、ATG 和低劑量 TBI；在 graft 端則移除 TCRαβ T 細胞來降低 GVHD。另一個訊息是 donor 的普及性，haplo donor 幾乎人人都有，對 MUD 機率不到 18% 的 SCD 病人特別重要。</a:t>
+            </a:r>
+          </a:p>
         </p:txBody>
       </p:sp>
       <p:sp>
@@ -3990,6 +4210,17 @@
             <a:r>
               <a:rPr lang="en-US" dirty="0"/>
               <a:t>即使部分病人已有核准的 gene addition therapy，matched family donor 移植仍被視為唯一的標準根治方法。它帶來終身脫離輸血，組織鐵負荷可以逆轉，生活品質也會改善。</a:t>
+            </a:r>
+          </a:p>
+          <a:p>
+            <a:pPr>
+              <a:spcAft>
+                <a:spcPts val="600"/>
+              </a:spcAft>
+            </a:pPr>
+            <a:r>
+              <a:rPr lang="en-US" dirty="0"/>
+              <a:t>HCT 的好處不只脫離輸血。書上引用的長期追蹤顯示，移植後肝硬化有機會逆轉，移植二十年以後的生活品質仍然良好。決定時要拿移植的風險，去和一輩子輸血與螯合的負擔相比。</a:t>
             </a:r>
           </a:p>
         </p:txBody>
@@ -12898,7 +13129,7 @@
                   <a:schemeClr val="tx1"/>
                 </a:solidFill>
               </a:rPr>
-              <a:t>An 8-year-old girl with transfusion-dependent β-thalassaemia received matched sibling bone marrow after fludarabine, treosulfan, thiotepa and ATG. She is transfusion independent with no GVHD. Over two months her donor chimerism has fallen from 95% to 70%; the recipient cells are mainly T cells. What is the best next step?</a:t>
+              <a:t>An 8-year-old girl with transfusion-dependent β-thalassaemia received matched sibling bone marrow after fludarabine, treosulfan, thiotepa and ATG. She is transfusion independent with no GVHD. Her donor chimerism has fallen from 95% to 70% in two months; the recipient cells are mainly T cells. What is the best next step?</a:t>
             </a:r>
             <a:endParaRPr lang="en-US" sz="1900" dirty="0"/>
           </a:p>

</xml_diff>

<commit_message>
Slides: sessions 21 and 23; verify-ledger generator
Co-Authored-By: Claude Opus 5.5 <noreply@anthropic.com>
Claude-Session: https://claude.ai/code/session_01XkzKv8pUGMF9AsqSCMpnBq
</commit_message>
<xml_diff>
--- a/slides/decks/s26-hemoglobinopathies.pptx
+++ b/slides/decks/s26-hemoglobinopathies.pptx
@@ -135,13 +135,13 @@
   <p:extLst>
     <p:ext uri="{521415D9-36F7-43E2-AB2F-B90AF26B5E84}">
       <p14:sectionLst xmlns:p14="http://schemas.microsoft.com/office/powerpoint/2010/main">
-        <p14:section name="Opening" id="{3699ab48-435f-76f1-aa1f-60b2fd7ce8c0}">
+        <p14:section name="Opening" id="{13e1337b-7b76-1b50-3c08-47156f2b7d8d}">
           <p14:sldIdLst>
             <p14:sldId id="256"/>
             <p14:sldId id="257"/>
           </p14:sldIdLst>
         </p14:section>
-        <p14:section name="Sickle cell disease" id="{cbfd52d6-9618-fe38-c567-9a360bc394ea}">
+        <p14:section name="Sickle cell disease" id="{d1852494-1f8c-3976-73e0-35717bc99a07}">
           <p14:sldIdLst>
             <p14:sldId id="258"/>
             <p14:sldId id="259"/>
@@ -149,13 +149,13 @@
             <p14:sldId id="261"/>
           </p14:sldIdLst>
         </p14:section>
-        <p14:section name="SCD conditioning and donors" id="{622b7127-ed7b-8e99-a0ad-a676c15f5bcb}">
+        <p14:section name="SCD conditioning and donors" id="{bf37dfaf-e8c9-325d-43c9-e9a973d3314d}">
           <p14:sldIdLst>
             <p14:sldId id="262"/>
             <p14:sldId id="263"/>
           </p14:sldIdLst>
         </p14:section>
-        <p14:section name="Thalassaemia" id="{2d2f0997-0542-76b5-862a-60b2b0df5885}">
+        <p14:section name="Thalassaemia" id="{febd081c-f196-9a96-cc24-a3da3de9e6dc}">
           <p14:sldIdLst>
             <p14:sldId id="264"/>
             <p14:sldId id="265"/>
@@ -164,14 +164,14 @@
             <p14:sldId id="268"/>
           </p14:sldIdLst>
         </p14:section>
-        <p14:section name="Chimerism, gene therapy and follow-up" id="{77b17c09-a34c-6258-58b4-80f3fd7b0236}">
+        <p14:section name="Chimerism, gene therapy and follow-up" id="{212688a8-5e48-a77d-8b2c-dce471aae346}">
           <p14:sldIdLst>
             <p14:sldId id="269"/>
             <p14:sldId id="270"/>
             <p14:sldId id="271"/>
           </p14:sldIdLst>
         </p14:section>
-        <p14:section name="Board questions" id="{5c72cbe7-b45f-a21b-c220-f85ed8619894}">
+        <p14:section name="Board questions" id="{9d829281-0c04-2985-3e07-744ee02c616d}">
           <p14:sldIdLst>
             <p14:sldId id="272"/>
             <p14:sldId id="273"/>
@@ -181,7 +181,7 @@
             <p14:sldId id="277"/>
           </p14:sldIdLst>
         </p14:section>
-        <p14:section name="References" id="{3487e8f9-c745-7e4b-d4f6-1ea726e9d9ee}">
+        <p14:section name="References" id="{6f8188ed-9ac8-750b-f317-8379f8701fbd}">
           <p14:sldIdLst>
             <p14:sldId id="278"/>
             <p14:sldId id="279"/>
@@ -189,7 +189,7 @@
             <p14:sldId id="281"/>
           </p14:sldIdLst>
         </p14:section>
-        <p14:section name="Backup" id="{0df5e680-e577-2991-82fa-5d66ef934c09}">
+        <p14:section name="Backup" id="{aba4849a-2b61-4fae-bf03-c15d91a540ba}">
           <p14:sldIdLst>
             <p14:sldId id="282"/>
             <p14:sldId id="283"/>
@@ -5929,20 +5929,6 @@
                       </a:r>
                       <a:endParaRPr lang="en-US" sz="2000" dirty="0"/>
                     </a:p>
-                    <a:p>
-                      <a:pPr indent="0" marL="0">
-                        <a:buNone/>
-                      </a:pPr>
-                      <a:r>
-                        <a:rPr lang="en-US" sz="2000" dirty="0">
-                          <a:solidFill>
-                            <a:schemeClr val="tx1"/>
-                          </a:solidFill>
-                        </a:rPr>
-                        <a:t>present</a:t>
-                      </a:r>
-                      <a:endParaRPr lang="en-US" sz="2000" dirty="0"/>
-                    </a:p>
                   </a:txBody>
                   <a:tcPr marL="25400" marR="101600" marT="63500" marB="63500" anchor="ctr">
                     <a:lnL w="0" cap="flat" cmpd="sng" algn="ctr">
@@ -6105,20 +6091,6 @@
                       </a:r>
                       <a:endParaRPr lang="en-US" sz="2000" dirty="0"/>
                     </a:p>
-                    <a:p>
-                      <a:pPr indent="0" marL="0">
-                        <a:buNone/>
-                      </a:pPr>
-                      <a:r>
-                        <a:rPr lang="en-US" sz="2000" dirty="0">
-                          <a:solidFill>
-                            <a:schemeClr val="tx1"/>
-                          </a:solidFill>
-                        </a:rPr>
-                        <a:t>present</a:t>
-                      </a:r>
-                      <a:endParaRPr lang="en-US" sz="2000" dirty="0"/>
-                    </a:p>
                   </a:txBody>
                   <a:tcPr marL="25400" marR="101600" marT="63500" marB="63500" anchor="ctr">
                     <a:lnL w="0" cap="flat" cmpd="sng" algn="ctr">
@@ -6281,20 +6253,6 @@
                       </a:r>
                       <a:endParaRPr lang="en-US" sz="2000" dirty="0"/>
                     </a:p>
-                    <a:p>
-                      <a:pPr indent="0" marL="0">
-                        <a:buNone/>
-                      </a:pPr>
-                      <a:r>
-                        <a:rPr lang="en-US" sz="2000" dirty="0">
-                          <a:solidFill>
-                            <a:schemeClr val="tx1"/>
-                          </a:solidFill>
-                        </a:rPr>
-                        <a:t>present</a:t>
-                      </a:r>
-                      <a:endParaRPr lang="en-US" sz="2000" dirty="0"/>
-                    </a:p>
                   </a:txBody>
                   <a:tcPr marL="25400" marR="101600" marT="63500" marB="63500" anchor="ctr">
                     <a:lnL w="0" cap="flat" cmpd="sng" algn="ctr">
@@ -6370,7 +6328,7 @@
         </p:nvSpPr>
         <p:spPr>
           <a:xfrm>
-            <a:off x="685800" y="4572000"/>
+            <a:off x="685800" y="4297680"/>
             <a:ext cx="10817352" cy="411480"/>
           </a:xfrm>
           <a:prstGeom prst="rect">
@@ -12218,7 +12176,21 @@
                   <a:schemeClr val="bg1"/>
                 </a:solidFill>
               </a:rPr>
-              <a:t>Deferasirox 20 mg/kg/d after ≥ 6 mo, for 1 y</a:t>
+              <a:t>Deferasirox 20 mg/kg/d</a:t>
+            </a:r>
+            <a:endParaRPr lang="en-US" sz="1700" dirty="0"/>
+          </a:p>
+          <a:p>
+            <a:pPr algn="ctr" indent="0" marL="0">
+              <a:buNone/>
+            </a:pPr>
+            <a:r>
+              <a:rPr lang="en-US" sz="1700" dirty="0">
+                <a:solidFill>
+                  <a:schemeClr val="bg1"/>
+                </a:solidFill>
+              </a:rPr>
+              <a:t>from ≥ 6 mo, for 1 y</a:t>
             </a:r>
             <a:endParaRPr lang="en-US" sz="1700" dirty="0"/>
           </a:p>
@@ -19222,7 +19194,7 @@
                   <a:schemeClr val="tx1"/>
                 </a:solidFill>
               </a:rPr>
-              <a:t>Fig. 80.1: transplants in adult SCD rose steeply over the decade; children with thalassaemia remain the largest group</a:t>
+              <a:t>Fig. 80.1: transplants in adult SCD rose steeply over the last decade</a:t>
             </a:r>
             <a:endParaRPr lang="en-US" sz="1600" dirty="0"/>
           </a:p>

</xml_diff>